<commit_message>
fix(affiches station): A4 + 32x45 pour 5 stations (PPTX+PDF+PNG), bandeau blanc unique remplace par pastille par logo (lisibilite), NOS PARTENAIRES descendu (ne mord plus sur JOUE), QR par station verifie
</commit_message>
<xml_diff>
--- a/admin/public/nds/kit-digital/nds/station-jeu_32x45_bar-1_editable.pptx
+++ b/admin/public/nds/kit-digital/nds/station-jeu_32x45_bar-1_editable.pptx
@@ -3429,7 +3429,7 @@
         </p:nvSpPr>
         <p:spPr>
           <a:xfrm>
-            <a:off x="460819" y="11583201"/>
+            <a:off x="460819" y="11945661"/>
             <a:ext cx="10598855" cy="891015"/>
           </a:xfrm>
           <a:prstGeom prst="rect">
@@ -3458,18 +3458,18 @@
       </p:sp>
       <p:sp>
         <p:nvSpPr>
-          <p:cNvPr id="12" name="Rounded Rectangle 11"/>
+          <p:cNvPr id="21" name="Rounded Rectangle 20"/>
           <p:cNvSpPr/>
           <p:nvPr/>
         </p:nvSpPr>
         <p:spPr>
           <a:xfrm>
-            <a:off x="714836" y="12545060"/>
-            <a:ext cx="10368445" cy="1215021"/>
+            <a:off x="759097" y="12390078"/>
+            <a:ext cx="2088693" cy="1333432"/>
           </a:xfrm>
           <a:prstGeom prst="roundRect">
             <a:avLst>
-              <a:gd name="adj" fmla="val 25000"/>
+              <a:gd name="adj" fmla="val 18000"/>
             </a:avLst>
           </a:prstGeom>
           <a:solidFill>
@@ -3478,6 +3478,7 @@
           <a:ln>
             <a:noFill/>
           </a:ln>
+          <a:effectLst/>
         </p:spPr>
         <p:style>
           <a:lnRef idx="1">
@@ -3498,7 +3499,6 @@
           <a:lstStyle/>
           <a:p>
             <a:pPr algn="ctr"/>
-            <a:endParaRPr/>
           </a:p>
         </p:txBody>
       </p:sp>
@@ -3526,6 +3526,52 @@
           </a:prstGeom>
         </p:spPr>
       </p:pic>
+      <p:sp>
+        <p:nvSpPr>
+          <p:cNvPr id="22" name="Rounded Rectangle 21"/>
+          <p:cNvSpPr/>
+          <p:nvPr/>
+        </p:nvSpPr>
+        <p:spPr>
+          <a:xfrm>
+            <a:off x="9305847" y="12245439"/>
+            <a:ext cx="1701929" cy="1728537"/>
+          </a:xfrm>
+          <a:prstGeom prst="roundRect">
+            <a:avLst>
+              <a:gd name="adj" fmla="val 18000"/>
+            </a:avLst>
+          </a:prstGeom>
+          <a:solidFill>
+            <a:srgbClr val="FFFFFF"/>
+          </a:solidFill>
+          <a:ln>
+            <a:noFill/>
+          </a:ln>
+          <a:effectLst/>
+        </p:spPr>
+        <p:style>
+          <a:lnRef idx="1">
+            <a:schemeClr val="accent1"/>
+          </a:lnRef>
+          <a:fillRef idx="3">
+            <a:schemeClr val="accent1"/>
+          </a:fillRef>
+          <a:effectRef idx="2">
+            <a:schemeClr val="accent1"/>
+          </a:effectRef>
+          <a:fontRef idx="minor">
+            <a:schemeClr val="lt1"/>
+          </a:fontRef>
+        </p:style>
+        <p:txBody>
+          <a:bodyPr rtlCol="0" anchor="ctr"/>
+          <a:lstStyle/>
+          <a:p>
+            <a:pPr algn="ctr"/>
+          </a:p>
+        </p:txBody>
+      </p:sp>
       <p:pic>
         <p:nvPicPr>
           <p:cNvPr id="14" name="Picture 13" descr="carrosserie-gp.png"/>
@@ -3550,6 +3596,52 @@
           </a:prstGeom>
         </p:spPr>
       </p:pic>
+      <p:sp>
+        <p:nvSpPr>
+          <p:cNvPr id="23" name="Rounded Rectangle 22"/>
+          <p:cNvSpPr/>
+          <p:nvPr/>
+        </p:nvSpPr>
+        <p:spPr>
+          <a:xfrm>
+            <a:off x="4116269" y="12626176"/>
+            <a:ext cx="3287457" cy="1024505"/>
+          </a:xfrm>
+          <a:prstGeom prst="roundRect">
+            <a:avLst>
+              <a:gd name="adj" fmla="val 18000"/>
+            </a:avLst>
+          </a:prstGeom>
+          <a:solidFill>
+            <a:srgbClr val="FFFFFF"/>
+          </a:solidFill>
+          <a:ln>
+            <a:noFill/>
+          </a:ln>
+          <a:effectLst/>
+        </p:spPr>
+        <p:style>
+          <a:lnRef idx="1">
+            <a:schemeClr val="accent1"/>
+          </a:lnRef>
+          <a:fillRef idx="3">
+            <a:schemeClr val="accent1"/>
+          </a:fillRef>
+          <a:effectRef idx="2">
+            <a:schemeClr val="accent1"/>
+          </a:effectRef>
+          <a:fontRef idx="minor">
+            <a:schemeClr val="lt1"/>
+          </a:fontRef>
+        </p:style>
+        <p:txBody>
+          <a:bodyPr rtlCol="0" anchor="ctr"/>
+          <a:lstStyle/>
+          <a:p>
+            <a:pPr algn="ctr"/>
+          </a:p>
+        </p:txBody>
+      </p:sp>
       <p:pic>
         <p:nvPicPr>
           <p:cNvPr id="15" name="Picture 14" descr="pegase.png"/>
@@ -3574,6 +3666,52 @@
           </a:prstGeom>
         </p:spPr>
       </p:pic>
+      <p:sp>
+        <p:nvSpPr>
+          <p:cNvPr id="24" name="Rounded Rectangle 23"/>
+          <p:cNvSpPr/>
+          <p:nvPr/>
+        </p:nvSpPr>
+        <p:spPr>
+          <a:xfrm>
+            <a:off x="2828917" y="12604564"/>
+            <a:ext cx="1347497" cy="1187802"/>
+          </a:xfrm>
+          <a:prstGeom prst="roundRect">
+            <a:avLst>
+              <a:gd name="adj" fmla="val 18000"/>
+            </a:avLst>
+          </a:prstGeom>
+          <a:solidFill>
+            <a:srgbClr val="FFFFFF"/>
+          </a:solidFill>
+          <a:ln>
+            <a:noFill/>
+          </a:ln>
+          <a:effectLst/>
+        </p:spPr>
+        <p:style>
+          <a:lnRef idx="1">
+            <a:schemeClr val="accent1"/>
+          </a:lnRef>
+          <a:fillRef idx="3">
+            <a:schemeClr val="accent1"/>
+          </a:fillRef>
+          <a:effectRef idx="2">
+            <a:schemeClr val="accent1"/>
+          </a:effectRef>
+          <a:fontRef idx="minor">
+            <a:schemeClr val="lt1"/>
+          </a:fontRef>
+        </p:style>
+        <p:txBody>
+          <a:bodyPr rtlCol="0" anchor="ctr"/>
+          <a:lstStyle/>
+          <a:p>
+            <a:pPr algn="ctr"/>
+          </a:p>
+        </p:txBody>
+      </p:sp>
       <p:pic>
         <p:nvPicPr>
           <p:cNvPr id="16" name="Picture 15" descr="charvolin.png"/>
@@ -3598,6 +3736,52 @@
           </a:prstGeom>
         </p:spPr>
       </p:pic>
+      <p:sp>
+        <p:nvSpPr>
+          <p:cNvPr id="25" name="Rounded Rectangle 24"/>
+          <p:cNvSpPr/>
+          <p:nvPr/>
+        </p:nvSpPr>
+        <p:spPr>
+          <a:xfrm>
+            <a:off x="7175868" y="12414827"/>
+            <a:ext cx="2310516" cy="1361126"/>
+          </a:xfrm>
+          <a:prstGeom prst="roundRect">
+            <a:avLst>
+              <a:gd name="adj" fmla="val 18000"/>
+            </a:avLst>
+          </a:prstGeom>
+          <a:solidFill>
+            <a:srgbClr val="FFFFFF"/>
+          </a:solidFill>
+          <a:ln>
+            <a:noFill/>
+          </a:ln>
+          <a:effectLst/>
+        </p:spPr>
+        <p:style>
+          <a:lnRef idx="1">
+            <a:schemeClr val="accent1"/>
+          </a:lnRef>
+          <a:fillRef idx="3">
+            <a:schemeClr val="accent1"/>
+          </a:fillRef>
+          <a:effectRef idx="2">
+            <a:schemeClr val="accent1"/>
+          </a:effectRef>
+          <a:fontRef idx="minor">
+            <a:schemeClr val="lt1"/>
+          </a:fontRef>
+        </p:style>
+        <p:txBody>
+          <a:bodyPr rtlCol="0" anchor="ctr"/>
+          <a:lstStyle/>
+          <a:p>
+            <a:pPr algn="ctr"/>
+          </a:p>
+        </p:txBody>
+      </p:sp>
       <p:pic>
         <p:nvPicPr>
           <p:cNvPr id="17" name="Picture 16" descr="nook.png"/>

</xml_diff>

<commit_message>
feat(affiches): partenaires 32x45 PDF (7) + stations A4/32x45 bandeau blanc RESTAURE (pastilles retirees), NOS PARTENAIRES descendu
</commit_message>
<xml_diff>
--- a/admin/public/nds/kit-digital/nds/station-jeu_32x45_bar-1_editable.pptx
+++ b/admin/public/nds/kit-digital/nds/station-jeu_32x45_bar-1_editable.pptx
@@ -3458,18 +3458,18 @@
       </p:sp>
       <p:sp>
         <p:nvSpPr>
-          <p:cNvPr id="21" name="Rounded Rectangle 20"/>
+          <p:cNvPr id="12" name="Rounded Rectangle 11"/>
           <p:cNvSpPr/>
           <p:nvPr/>
         </p:nvSpPr>
         <p:spPr>
           <a:xfrm>
-            <a:off x="759097" y="12390078"/>
-            <a:ext cx="2088693" cy="1333432"/>
+            <a:off x="714836" y="12545060"/>
+            <a:ext cx="10368445" cy="1215021"/>
           </a:xfrm>
           <a:prstGeom prst="roundRect">
             <a:avLst>
-              <a:gd name="adj" fmla="val 18000"/>
+              <a:gd name="adj" fmla="val 25000"/>
             </a:avLst>
           </a:prstGeom>
           <a:solidFill>
@@ -3478,7 +3478,6 @@
           <a:ln>
             <a:noFill/>
           </a:ln>
-          <a:effectLst/>
         </p:spPr>
         <p:style>
           <a:lnRef idx="1">
@@ -3499,6 +3498,7 @@
           <a:lstStyle/>
           <a:p>
             <a:pPr algn="ctr"/>
+            <a:endParaRPr/>
           </a:p>
         </p:txBody>
       </p:sp>
@@ -3526,52 +3526,6 @@
           </a:prstGeom>
         </p:spPr>
       </p:pic>
-      <p:sp>
-        <p:nvSpPr>
-          <p:cNvPr id="22" name="Rounded Rectangle 21"/>
-          <p:cNvSpPr/>
-          <p:nvPr/>
-        </p:nvSpPr>
-        <p:spPr>
-          <a:xfrm>
-            <a:off x="9305847" y="12245439"/>
-            <a:ext cx="1701929" cy="1728537"/>
-          </a:xfrm>
-          <a:prstGeom prst="roundRect">
-            <a:avLst>
-              <a:gd name="adj" fmla="val 18000"/>
-            </a:avLst>
-          </a:prstGeom>
-          <a:solidFill>
-            <a:srgbClr val="FFFFFF"/>
-          </a:solidFill>
-          <a:ln>
-            <a:noFill/>
-          </a:ln>
-          <a:effectLst/>
-        </p:spPr>
-        <p:style>
-          <a:lnRef idx="1">
-            <a:schemeClr val="accent1"/>
-          </a:lnRef>
-          <a:fillRef idx="3">
-            <a:schemeClr val="accent1"/>
-          </a:fillRef>
-          <a:effectRef idx="2">
-            <a:schemeClr val="accent1"/>
-          </a:effectRef>
-          <a:fontRef idx="minor">
-            <a:schemeClr val="lt1"/>
-          </a:fontRef>
-        </p:style>
-        <p:txBody>
-          <a:bodyPr rtlCol="0" anchor="ctr"/>
-          <a:lstStyle/>
-          <a:p>
-            <a:pPr algn="ctr"/>
-          </a:p>
-        </p:txBody>
-      </p:sp>
       <p:pic>
         <p:nvPicPr>
           <p:cNvPr id="14" name="Picture 13" descr="carrosserie-gp.png"/>
@@ -3596,52 +3550,6 @@
           </a:prstGeom>
         </p:spPr>
       </p:pic>
-      <p:sp>
-        <p:nvSpPr>
-          <p:cNvPr id="23" name="Rounded Rectangle 22"/>
-          <p:cNvSpPr/>
-          <p:nvPr/>
-        </p:nvSpPr>
-        <p:spPr>
-          <a:xfrm>
-            <a:off x="4116269" y="12626176"/>
-            <a:ext cx="3287457" cy="1024505"/>
-          </a:xfrm>
-          <a:prstGeom prst="roundRect">
-            <a:avLst>
-              <a:gd name="adj" fmla="val 18000"/>
-            </a:avLst>
-          </a:prstGeom>
-          <a:solidFill>
-            <a:srgbClr val="FFFFFF"/>
-          </a:solidFill>
-          <a:ln>
-            <a:noFill/>
-          </a:ln>
-          <a:effectLst/>
-        </p:spPr>
-        <p:style>
-          <a:lnRef idx="1">
-            <a:schemeClr val="accent1"/>
-          </a:lnRef>
-          <a:fillRef idx="3">
-            <a:schemeClr val="accent1"/>
-          </a:fillRef>
-          <a:effectRef idx="2">
-            <a:schemeClr val="accent1"/>
-          </a:effectRef>
-          <a:fontRef idx="minor">
-            <a:schemeClr val="lt1"/>
-          </a:fontRef>
-        </p:style>
-        <p:txBody>
-          <a:bodyPr rtlCol="0" anchor="ctr"/>
-          <a:lstStyle/>
-          <a:p>
-            <a:pPr algn="ctr"/>
-          </a:p>
-        </p:txBody>
-      </p:sp>
       <p:pic>
         <p:nvPicPr>
           <p:cNvPr id="15" name="Picture 14" descr="pegase.png"/>
@@ -3666,52 +3574,6 @@
           </a:prstGeom>
         </p:spPr>
       </p:pic>
-      <p:sp>
-        <p:nvSpPr>
-          <p:cNvPr id="24" name="Rounded Rectangle 23"/>
-          <p:cNvSpPr/>
-          <p:nvPr/>
-        </p:nvSpPr>
-        <p:spPr>
-          <a:xfrm>
-            <a:off x="2828917" y="12604564"/>
-            <a:ext cx="1347497" cy="1187802"/>
-          </a:xfrm>
-          <a:prstGeom prst="roundRect">
-            <a:avLst>
-              <a:gd name="adj" fmla="val 18000"/>
-            </a:avLst>
-          </a:prstGeom>
-          <a:solidFill>
-            <a:srgbClr val="FFFFFF"/>
-          </a:solidFill>
-          <a:ln>
-            <a:noFill/>
-          </a:ln>
-          <a:effectLst/>
-        </p:spPr>
-        <p:style>
-          <a:lnRef idx="1">
-            <a:schemeClr val="accent1"/>
-          </a:lnRef>
-          <a:fillRef idx="3">
-            <a:schemeClr val="accent1"/>
-          </a:fillRef>
-          <a:effectRef idx="2">
-            <a:schemeClr val="accent1"/>
-          </a:effectRef>
-          <a:fontRef idx="minor">
-            <a:schemeClr val="lt1"/>
-          </a:fontRef>
-        </p:style>
-        <p:txBody>
-          <a:bodyPr rtlCol="0" anchor="ctr"/>
-          <a:lstStyle/>
-          <a:p>
-            <a:pPr algn="ctr"/>
-          </a:p>
-        </p:txBody>
-      </p:sp>
       <p:pic>
         <p:nvPicPr>
           <p:cNvPr id="16" name="Picture 15" descr="charvolin.png"/>
@@ -3736,52 +3598,6 @@
           </a:prstGeom>
         </p:spPr>
       </p:pic>
-      <p:sp>
-        <p:nvSpPr>
-          <p:cNvPr id="25" name="Rounded Rectangle 24"/>
-          <p:cNvSpPr/>
-          <p:nvPr/>
-        </p:nvSpPr>
-        <p:spPr>
-          <a:xfrm>
-            <a:off x="7175868" y="12414827"/>
-            <a:ext cx="2310516" cy="1361126"/>
-          </a:xfrm>
-          <a:prstGeom prst="roundRect">
-            <a:avLst>
-              <a:gd name="adj" fmla="val 18000"/>
-            </a:avLst>
-          </a:prstGeom>
-          <a:solidFill>
-            <a:srgbClr val="FFFFFF"/>
-          </a:solidFill>
-          <a:ln>
-            <a:noFill/>
-          </a:ln>
-          <a:effectLst/>
-        </p:spPr>
-        <p:style>
-          <a:lnRef idx="1">
-            <a:schemeClr val="accent1"/>
-          </a:lnRef>
-          <a:fillRef idx="3">
-            <a:schemeClr val="accent1"/>
-          </a:fillRef>
-          <a:effectRef idx="2">
-            <a:schemeClr val="accent1"/>
-          </a:effectRef>
-          <a:fontRef idx="minor">
-            <a:schemeClr val="lt1"/>
-          </a:fontRef>
-        </p:style>
-        <p:txBody>
-          <a:bodyPr rtlCol="0" anchor="ctr"/>
-          <a:lstStyle/>
-          <a:p>
-            <a:pPr algn="ctr"/>
-          </a:p>
-        </p:txBody>
-      </p:sp>
       <p:pic>
         <p:nvPicPr>
           <p:cNvPr id="17" name="Picture 16" descr="nook.png"/>

</xml_diff>